<commit_message>
Greg Anderson: estate webinar complete (45 slides, 6,870 words, gate 8.4); estate registration funnel built and tested
Co-Authored-By: Claude Opus 5.5 <noreply@anthropic.com>
Claude-Session: https://claude.ai/code/session_01MRtipqYfL1Z8BYWb1K5nPs
</commit_message>
<xml_diff>
--- a/clients/greg-anderson/06-webinars/estate-planning/build/who-decides-when-you-can-t.pptx
+++ b/clients/greg-anderson/06-webinars/estate-planning/build/who-decides-when-you-can-t.pptx
@@ -8637,7 +8637,7 @@
                 </a:solidFill>
                 <a:latin typeface="Source Sans 3"/>
               </a:rPr>
-              <a:t>Educational only. Not legal, tax, or investment advice. Estate documents are prepared by a licensed attorney. Insurance or investment products may be discussed in a private meeting. [PLACEHOLDER: Greg's required RIA and insurance disclosure, pending his approver.]</a:t>
+              <a:t>Educational only. Not legal, tax, or investment advice. A licensed attorney prepares estate documents. [PLACEHOLDER: required RIA/insurance disclosure]</a:t>
             </a:r>
           </a:p>
         </p:txBody>
@@ -13796,7 +13796,7 @@
                 </a:solidFill>
                 <a:latin typeface="Source Sans 3"/>
               </a:rPr>
-              <a:t>Retitle accounts and the house, or the trust sits empty</a:t>
+              <a:t>Retitle accounts and home, or it sits empty</a:t>
             </a:r>
           </a:p>
         </p:txBody>
@@ -13954,7 +13954,7 @@
                 </a:solidFill>
                 <a:latin typeface="Source Sans 3"/>
               </a:rPr>
-              <a:t>An outright inheritance can upset needs-based benefits</a:t>
+              <a:t>Money left outright can upset benefits</a:t>
             </a:r>
           </a:p>
         </p:txBody>
@@ -18031,7 +18031,7 @@
                 </a:solidFill>
                 <a:latin typeface="Source Sans 3"/>
               </a:rPr>
-              <a:t>Educational only. Not legal, tax, or investment advice. Estate documents are prepared by a licensed attorney. Insurance or investment products may be discussed in a private meeting. [PLACEHOLDER: Greg's required RIA and insurance disclosure, pending his approver.]</a:t>
+              <a:t>Educational only. Not legal, tax, or investment advice. A licensed attorney prepares estate documents. [PLACEHOLDER: required RIA/insurance disclosure]</a:t>
             </a:r>
           </a:p>
         </p:txBody>
@@ -18898,7 +18898,7 @@
                 </a:solidFill>
                 <a:latin typeface="Source Sans 3"/>
               </a:rPr>
-              <a:t>Educational only. Not legal, tax, or investment advice. Estate documents are prepared by a licensed attorney. Insurance or investment products may be discussed in a private meeting. [PLACEHOLDER: Greg's required RIA and insurance disclosure, pending his approver.]</a:t>
+              <a:t>Educational only. Not legal, tax, or investment advice. A licensed attorney prepares estate documents. [PLACEHOLDER: required RIA/insurance disclosure]</a:t>
             </a:r>
           </a:p>
         </p:txBody>
@@ -19633,7 +19633,7 @@
                 </a:solidFill>
                 <a:latin typeface="Source Sans 3"/>
               </a:rPr>
-              <a:t>1. 1. What really happens</a:t>
+              <a:t>1. What really happens</a:t>
             </a:r>
           </a:p>
         </p:txBody>
@@ -19791,7 +19791,7 @@
                 </a:solidFill>
                 <a:latin typeface="Source Sans 3"/>
               </a:rPr>
-              <a:t>2. 2. The overlooked pieces</a:t>
+              <a:t>2. The overlooked pieces</a:t>
             </a:r>
           </a:p>
         </p:txBody>
@@ -19949,7 +19949,7 @@
                 </a:solidFill>
                 <a:latin typeface="Source Sans 3"/>
               </a:rPr>
-              <a:t>3. 3. A simple checklist</a:t>
+              <a:t>3. A simple checklist</a:t>
             </a:r>
           </a:p>
         </p:txBody>

</xml_diff>